<commit_message>
PowerPoint workflows: consistent review deck (Q3 up 18%, per-series fills), labelled bars asked for, notes counted as new sentences, no copied notes on an added slide, two-fact question is level 2
</commit_message>
<xml_diff>
--- a/artifacts/quarterly-review.pptx
+++ b/artifacts/quarterly-review.pptx
@@ -135,6 +135,11 @@
               </c:strCache>
             </c:strRef>
           </c:tx>
+          <c:spPr>
+            <a:solidFill>
+              <a:schemeClr val="accent1"/>
+            </a:solidFill>
+          </c:spPr>
           <c:cat>
             <c:strRef>
               <c:f>Sheet1!$A$2:$A$5</c:f>
@@ -162,16 +167,16 @@
                 <c:formatCode>General</c:formatCode>
                 <c:ptCount val="4"/>
                 <c:pt idx="0">
-                  <c:v>4.1</c:v>
+                  <c:v>4.0</c:v>
                 </c:pt>
                 <c:pt idx="1">
-                  <c:v>3.2</c:v>
+                  <c:v>3.1</c:v>
                 </c:pt>
                 <c:pt idx="2">
-                  <c:v>2.7</c:v>
+                  <c:v>2.6</c:v>
                 </c:pt>
                 <c:pt idx="3">
-                  <c:v>1.9</c:v>
+                  <c:v>2.3</c:v>
                 </c:pt>
               </c:numCache>
             </c:numRef>
@@ -191,6 +196,11 @@
               </c:strCache>
             </c:strRef>
           </c:tx>
+          <c:spPr>
+            <a:solidFill>
+              <a:schemeClr val="accent2"/>
+            </a:solidFill>
+          </c:spPr>
           <c:cat>
             <c:strRef>
               <c:f>Sheet1!$A$2:$A$5</c:f>
@@ -224,10 +234,10 @@
                   <c:v>3.5</c:v>
                 </c:pt>
                 <c:pt idx="2">
-                  <c:v>3.1</c:v>
+                  <c:v>3.2</c:v>
                 </c:pt>
                 <c:pt idx="3">
-                  <c:v>2.4</c:v>
+                  <c:v>2.7</c:v>
                 </c:pt>
               </c:numCache>
             </c:numRef>

</xml_diff>